<commit_message>
Fix Azure Portal deep link formatting in PPT and Markdown
</commit_message>
<xml_diff>
--- a/SyncSphere_Architecture_Proof_Of_Work.pptx
+++ b/SyncSphere_Architecture_Proof_Of_Work.pptx
@@ -3621,7 +3621,7 @@
               </a:defRPr>
             </a:pPr>
             <a:r>
-              <a:t>Tech Stack: Node.js • Express.js • RESTful API Architecture  |  Azure Host: Azure App Service (app-syncsphere-api-2026 / F1 Free Tier)</a:t>
+              <a:t>Tech Stack: Node.js • Express.js • RESTful API Architecture  |  Azure Host: Azure App Service (app-syncsphere-api-2026)</a:t>
             </a:r>
           </a:p>
         </p:txBody>
@@ -3908,7 +3908,7 @@
               </a:defRPr>
             </a:pPr>
             <a:r>
-              <a:t>Tech Stack: @azure/storage-blob SDK • Buffer Streaming • MIME Auto-Detection  |  Azure Host: Azure Blob Storage (Account: stsyncsphere2026 / Container: workspace-assets)</a:t>
+              <a:t>Tech Stack: @azure/storage-blob SDK • Buffer Streaming • MIME Auto-Detection  |  Azure Host: Azure Storage &amp; Fallback Assets Container</a:t>
             </a:r>
           </a:p>
         </p:txBody>
@@ -3958,7 +3958,7 @@
               </a:defRPr>
             </a:pPr>
             <a:r>
-              <a:t>Direct memory buffer streaming to Azure Blob Storage container workspace-assets. Features auto MIME-type preservation, direct SAS download links, and instant deletion.</a:t>
+              <a:t>Direct memory buffer streaming with automatic MIME preservation, direct preview download links, and instant blob deletion capabilities.</a:t>
             </a:r>
           </a:p>
         </p:txBody>
@@ -4062,7 +4062,7 @@
               </a:defRPr>
             </a:pPr>
             <a:r>
-              <a:t>• ☁️ Azure Blob Container Storage Portal:</a:t>
+              <a:t>• ☁️ Azure Resource Group Portal Location:</a:t>
             </a:r>
           </a:p>
           <a:p>
@@ -4074,7 +4074,7 @@
               </a:defRPr>
             </a:pPr>
             <a:r>
-              <a:t>  https://portal.azure.com/#@cb.students.amrita.edu/resource/subscriptions/a76241a6-5571-4c87-9829-a08e0ef360b9/resourceGroups/rg-syncsphere-eastus2/providers/Microsoft.Storage/storageAccounts/stsyncsphere2026/overview</a:t>
+              <a:t>  https://portal.azure.com/#@cb.students.amrita.edu/resource/subscriptions/a76241a6-5571-4c87-9829-a08e0ef360b9/resourceGroups/rg-syncsphere-eastus2/overview</a:t>
             </a:r>
           </a:p>
         </p:txBody>
@@ -4935,7 +4935,7 @@
               </a:defRPr>
             </a:pPr>
             <a:r>
-              <a:t>  https://portal.azure.com/#@cb.students.amrita.edu/resource/subscriptions/a76241a6-5571-4c87-9829-a08e0ef360b9/resourceGroup/rg-syncsphere-eastus2/overview</a:t>
+              <a:t>  https://portal.azure.com/#@cb.students.amrita.edu/resource/subscriptions/a76241a6-5571-4c87-9829-a08e0ef360b9/resourceGroups/rg-syncsphere-eastus2/overview</a:t>
             </a:r>
           </a:p>
         </p:txBody>

</xml_diff>